<commit_message>
Update midterm future work and current evaluation evidence
</commit_message>
<xml_diff>
--- a/assignments/2026-10-12/midterm/Midterm_Presentation_Final.pptx
+++ b/assignments/2026-10-12/midterm/Midterm_Presentation_Final.pptx
@@ -2,17 +2,17 @@
 <file path=ppt/presentation.xml><?xml version="1.0" encoding="utf-8"?>
 <p:presentation xmlns:p="http://schemas.openxmlformats.org/presentationml/2006/main">
   <p:sldMasterIdLst>
-    <p:sldMasterId xmlns:r="http://schemas.openxmlformats.org/officeDocument/2006/relationships" id="2147483648" r:id="Rb378b93d5a3a486d"/>
+    <p:sldMasterId xmlns:r="http://schemas.openxmlformats.org/officeDocument/2006/relationships" id="2147483648" r:id="R212afb4b361a4471"/>
   </p:sldMasterIdLst>
   <p:notesMasterIdLst>
-    <p:notesMasterId xmlns:r="http://schemas.openxmlformats.org/officeDocument/2006/relationships" r:id="Rf90cc0c7432c4459"/>
+    <p:notesMasterId xmlns:r="http://schemas.openxmlformats.org/officeDocument/2006/relationships" r:id="Rdd6591e13fa14b9d"/>
   </p:notesMasterIdLst>
   <p:sldIdLst>
-    <p:sldId xmlns:r="http://schemas.openxmlformats.org/officeDocument/2006/relationships" id="256" r:id="Rddf840d6fc234d24"/>
-    <p:sldId xmlns:r="http://schemas.openxmlformats.org/officeDocument/2006/relationships" id="257" r:id="R1e5b1e690f144a90"/>
-    <p:sldId xmlns:r="http://schemas.openxmlformats.org/officeDocument/2006/relationships" id="258" r:id="R5ed5eb14e2d0495a"/>
-    <p:sldId xmlns:r="http://schemas.openxmlformats.org/officeDocument/2006/relationships" id="259" r:id="R0e67b00be2934972"/>
-    <p:sldId xmlns:r="http://schemas.openxmlformats.org/officeDocument/2006/relationships" id="260" r:id="R6bdda8b91ef84ede"/>
+    <p:sldId xmlns:r="http://schemas.openxmlformats.org/officeDocument/2006/relationships" id="256" r:id="R0e4099f2f4914317"/>
+    <p:sldId xmlns:r="http://schemas.openxmlformats.org/officeDocument/2006/relationships" id="257" r:id="Rcf34c7009da6498d"/>
+    <p:sldId xmlns:r="http://schemas.openxmlformats.org/officeDocument/2006/relationships" id="258" r:id="Rf906329583084cb8"/>
+    <p:sldId xmlns:r="http://schemas.openxmlformats.org/officeDocument/2006/relationships" id="259" r:id="R1a906f9e4ab441d5"/>
+    <p:sldId xmlns:r="http://schemas.openxmlformats.org/officeDocument/2006/relationships" id="260" r:id="R12ef323c803f4a4c"/>
   </p:sldIdLst>
   <p:sldSz cx="12192000" cy="6858000"/>
   <p:notesSz cx="6858000" cy="9144000"/>
@@ -446,7 +446,7 @@
           <a:lstStyle xmlns:a="http://schemas.openxmlformats.org/drawingml/2006/main"/>
           <a:p xmlns:a="http://schemas.openxmlformats.org/drawingml/2006/main">
             <a:r>
-              <a:t>45 seconds. We built an assistant for a CSV and a natural-language research question. It produces an explicit plan, diagnoses the data, calls statistical tools and gives a reviewed explanation with uncertainty. A p-value can be numerically correct while the explanation uses the wrong target or implies causation. Our prototype makes those decisions visible. It supports four methods and runs through a CLI or notebook. The graph has seventeen workflow nodes but only two LLM agents, backed by different local models. Memory lasts for the running process.</a:t>
+              <a:t>45 seconds. We built an assistant for a CSV and a natural-language research question. It produces an explicit plan, diagnoses the data, calls statistical tools and gives a reviewed explanation with uncertainty. A p-value can be numerically correct while the explanation uses the wrong target or implies causation. Our prototype makes those decisions visible. It supports four methods and runs through a local browser UI, CLI or notebook. The graph has seventeen workflow nodes but only two LLM agents, backed by different local models. Memory lasts for the running process.</a:t>
             </a:r>
           </a:p>
           <a:p xmlns:a="http://schemas.openxmlformats.org/drawingml/2006/main">
@@ -456,7 +456,7 @@
           </a:p>
           <a:p xmlns:a="http://schemas.openxmlformats.org/drawingml/2006/main">
             <a:r>
-              <a:t>Sources: https://github.com/thisisbread1999/statistical-analysis-assistant/blob/9a8fa007c5165b75c2f3fc99a1f3d8fc51683fba/README.md ; https://github.com/thisisbread1999/statistical-analysis-assistant/blob/9a8fa007c5165b75c2f3fc99a1f3d8fc51683fba/stat_assistant/workflow.py</a:t>
+              <a:t>Sources: https://github.com/thisisbread1999/statistical-analysis-assistant/blob/4ebe82c/README.md ; https://github.com/thisisbread1999/statistical-analysis-assistant/blob/4ebe82c/stat_assistant/workflow.py ; https://github.com/thisisbread1999/statistical-analysis-assistant/blob/4ebe82c/ui_server.py</a:t>
             </a:r>
           </a:p>
         </p:txBody>
@@ -526,7 +526,7 @@
           <a:lstStyle xmlns:a="http://schemas.openxmlformats.org/drawingml/2006/main"/>
           <a:p xmlns:a="http://schemas.openxmlformats.org/drawingml/2006/main">
             <a:r>
-              <a:t>70 seconds. Qwen3 is Model A: it plans, reviews variable meanings and study design, drafts the report and revises when needed. Two diagnostic branches execute in parallel: the LLM checks semantic alignment, while Python checks raw values and method-specific computability. Both must finish before the routing decision. Correctable or verifiable data issues pause the graph; unsupported or unusable input stops. The user supplies a correction, exclusion or verification with a reason; the original data and change history are retained. Python then calculates the statistics. Program checks protect numerical fields, and Gemma3 independently reviews the rendered draft against the original evidence. One report revision is allowed. Persistent failure stops; a request also permits one plan revision, two answered clarification rounds and at most fifteen model calls. Two models can still share errors.</a:t>
+              <a:t>70 seconds. Qwen3 is Model A: it plans, checks variable meanings and study design, drafts the report and revises when needed. The LLM semantic diagnosis and Python value checks run in parallel. Both finish before routing. Correctable or verifiable data issues pause for a user decision. Users can correct, exclude or verify records, with optional notes. The original data and decision history remain available. Python calculates protected statistics. OLS also reports Cook's distance, leverage and a studentized Breusch-Pagan variance diagnostic. Flags describe potential problems and do not automatically remove records or change the estimator. Gemma3 independently reviews the rendered draft against the original evidence. One report revision is allowed before stopping. Requests also permit one plan revision, two answered clarification rounds and at most fifteen model calls. Two models can still share errors.</a:t>
             </a:r>
           </a:p>
           <a:p xmlns:a="http://schemas.openxmlformats.org/drawingml/2006/main">
@@ -536,7 +536,7 @@
           </a:p>
           <a:p xmlns:a="http://schemas.openxmlformats.org/drawingml/2006/main">
             <a:r>
-              <a:t>Sources: https://github.com/thisisbread1999/statistical-analysis-assistant/blob/9a8fa007c5165b75c2f3fc99a1f3d8fc51683fba/stat_assistant/nodes.py ; https://github.com/thisisbread1999/statistical-analysis-assistant/blob/9a8fa007c5165b75c2f3fc99a1f3d8fc51683fba/stat_assistant/settings.py ; https://github.com/thisisbread1999/statistical-analysis-assistant/blob/9a8fa007c5165b75c2f3fc99a1f3d8fc51683fba/stat_assistant/agents.py</a:t>
+              <a:t>Sources: https://github.com/thisisbread1999/statistical-analysis-assistant/blob/4ebe82c/stat_assistant/nodes.py ; https://github.com/thisisbread1999/statistical-analysis-assistant/blob/4ebe82c/stat_assistant/tools.py ; https://github.com/thisisbread1999/statistical-analysis-assistant/blob/4ebe82c/stat_assistant/settings.py ; https://github.com/thisisbread1999/statistical-analysis-assistant/blob/4ebe82c/stat_assistant/agents.py</a:t>
             </a:r>
           </a:p>
         </p:txBody>
@@ -606,7 +606,7 @@
           <a:lstStyle xmlns:a="http://schemas.openxmlformats.org/drawingml/2006/main"/>
           <a:p xmlns:a="http://schemas.openxmlformats.org/drawingml/2006/main">
             <a:r>
-              <a:t>80 seconds. Our own synthetic tutoring data contains eighty simulated students, forty in each group. Teaching metadata states independent records and voluntary, nonrandom tutoring; these are supplied scenario assumptions. Model A maps score to outcome and tutoring to the two-group variable. The target is mean score for yes minus no, with a two-sided null of zero and alpha point zero five. Welch answers this mean comparison and allows unequal variances. Normality diagnostics describe risks and do not automatically switch the target to a rank test. The means are 75.9525 and 69.035 points. SciPy gives a difference of 6.9175 points, a 95-percent interval from 2.9689 to 10.8661, t approximately 3.4927 with 71.4775 degrees of freedom, and p approximately 0.000824. We reject the null under the stated analysis assumptions. Nonrandom assignment means this result does not establish that tutoring caused higher scores.</a:t>
+              <a:t>80 seconds. Our synthetic tutoring data contains eighty simulated students, forty in each group. Teaching metadata states independent records and voluntary, nonrandom tutoring. These are supplied scenario assumptions. Model A maps score to outcome and tutoring to the two-group variable. The target is mean score for yes minus no, with a two-sided null of zero and alpha point zero five. Welch answers this mean comparison and allows unequal variances. Normality diagnostics describe risks and do not automatically change the target to a rank test. The means are 75.9525 and 69.035 points. SciPy gives a difference of 6.9175 points, a 95-percent interval from 2.9689 to 10.8661, t approximately 3.4927 with 71.4775 degrees of freedom, and p approximately 0.000824. We reject the null under the stated analysis assumptions. Nonrandom assignment means this result does not establish that tutoring caused higher scores.</a:t>
             </a:r>
           </a:p>
           <a:p xmlns:a="http://schemas.openxmlformats.org/drawingml/2006/main">
@@ -616,7 +616,7 @@
           </a:p>
           <a:p xmlns:a="http://schemas.openxmlformats.org/drawingml/2006/main">
             <a:r>
-              <a:t>Sources: https://github.com/thisisbread1999/statistical-analysis-assistant/blob/9a8fa007c5165b75c2f3fc99a1f3d8fc51683fba/examples/tutoring_scores_clean_synthetic.csv ; https://github.com/thisisbread1999/statistical-analysis-assistant/blob/9a8fa007c5165b75c2f3fc99a1f3d8fc51683fba/artifacts/verification/initial_full_real.json</a:t>
+              <a:t>Sources: https://github.com/thisisbread1999/statistical-analysis-assistant/blob/4ebe82c/examples/tutoring_scores_clean_synthetic.csv ; https://github.com/thisisbread1999/statistical-analysis-assistant/blob/4ebe82c/artifacts/verification/initial_full_real.json</a:t>
             </a:r>
           </a:p>
         </p:txBody>
@@ -686,7 +686,7 @@
           <a:lstStyle xmlns:a="http://schemas.openxmlformats.org/drawingml/2006/main"/>
           <a:p xmlns:a="http://schemas.openxmlformats.org/drawingml/2006/main">
             <a:r>
-              <a:t>55 seconds. Explanation-only follow-ups reuse the validated statistics but draft and review new prose. Asking for a 99-percent interval reuses the data, roles, design and diagnostics and reruns the statistical tool. The interval widens to about 1.68 through 12.16 points. Alpha remains point zero five, and the estimate and p-value do not change. Automatic date filtering is outside this implementation; a subset requires a new CSV and new checks. We passed ninety-three offline tests with mocked model responses and real statistical calculations. Historical Qwen3 and Gemma3 runs eventually delivered all four methods and follow-ups across an initial run and targeted development reruns. This is execution evidence, not a model accuracy benchmark. Independent human interpretation scoring is pending.</a:t>
+              <a:t>50 seconds. Explanation follow-ups reuse validated statistics but draft and review new prose. Asking for a 99-percent interval reruns the statistical tool using the existing data and design. The interval widens to about 1.68 through 12.16 points while alpha, estimate and p-value stay fixed. A subset requires a new CSV. We passed 192 software tests. Our live evaluation checked 31 adapted synthetic scenarios and passed 27 workflow checks. These checks measure prespecified behavior, not semantic accuracy. Assessed numerical outputs matched references in 19 of 19 cases. Including separate warm-up analyses, reviewers accepted 17 of 20 computed reports. A controlled challenge combining code checks and Model B accepted all four valid controls and caught ten of twelve planted errors. This is checker coverage. Human scoring remains pending.</a:t>
             </a:r>
           </a:p>
           <a:p xmlns:a="http://schemas.openxmlformats.org/drawingml/2006/main">
@@ -696,7 +696,7 @@
           </a:p>
           <a:p xmlns:a="http://schemas.openxmlformats.org/drawingml/2006/main">
             <a:r>
-              <a:t>Sources: https://github.com/thisisbread1999/statistical-analysis-assistant/blob/9a8fa007c5165b75c2f3fc99a1f3d8fc51683fba/docs/VERIFICATION.md ; https://github.com/thisisbread1999/statistical-analysis-assistant/blob/9a8fa007c5165b75c2f3fc99a1f3d8fc51683fba/stat_assistant/runtime.py ; https://github.com/thisisbread1999/statistical-analysis-assistant/blob/9a8fa007c5165b75c2f3fc99a1f3d8fc51683fba/artifacts/verification/layout_alignment.json</a:t>
+              <a:t>Sources: https://github.com/thisisbread1999/statistical-analysis-assistant/blob/4ebe82c/docs/VERIFICATION.md ; https://github.com/thisisbread1999/statistical-analysis-assistant/blob/4ebe82c/artifacts/benchmark_v2/20261012-live-blinded/REPORT.md ; https://github.com/thisisbread1999/statistical-analysis-assistant/blob/4ebe82c/artifacts/interpretation_checks/20261012-live-blinded/REPORT.md</a:t>
             </a:r>
           </a:p>
         </p:txBody>
@@ -766,7 +766,7 @@
           <a:lstStyle xmlns:a="http://schemas.openxmlformats.org/drawingml/2006/main"/>
           <a:p xmlns:a="http://schemas.openxmlformats.org/drawingml/2006/main">
             <a:r>
-              <a:t>50 seconds. A genuine failure occurred in the initial real Pearson and regression runs: their statistical calculations completed, but the report checker rejected a literal zero in the null hypothesis under its placeholder-only policy. Reports stopped after the permitted revision. Repairs added protected null values and decision and direction renderings and distinguished a null slope from an estimated slope. Final targeted runs delivered Pearson after one revision and regression on its first draft. We also observed reviewer false alarms about correctly rounded values. The next step is a held-out set with normal, ambiguous and failing cases, independently scored by both teammates for method choice, effect meaning, uncertainty, missingness and causal restraint. Missed errors and false alarms both matter.</a:t>
+              <a:t>55 seconds. We propose three extensions. First, people already participate by confirming record corrections or exclusions. The next evaluation layer is independent human scoring of method selection, numerical fidelity and statistical meaning. The CSV and rubric are ready, but no one has filled the ratings. Reviewers will score separately and resolve disagreements. Selective analyst review could help with unresolved cases in a later version. Second, the prototype currently supports four basic methods. We will add methods such as paired tests and multiple regression when the question and study design require them, with explicit targets and assumptions. Third, we will retain synthetic cases with known references and add curated public datasets, potentially from Kaggle. We will verify that the data have documented real-world origins and study design information. Experts will provide reference analyses and assess interpretations. Real datasets usually lack known population truth, so we cannot treat a plausible result as ground truth. These are planned extensions, not completed experiments.</a:t>
             </a:r>
           </a:p>
           <a:p xmlns:a="http://schemas.openxmlformats.org/drawingml/2006/main">
@@ -776,7 +776,7 @@
           </a:p>
           <a:p xmlns:a="http://schemas.openxmlformats.org/drawingml/2006/main">
             <a:r>
-              <a:t>Sources: https://github.com/thisisbread1999/statistical-analysis-assistant/blob/9a8fa007c5165b75c2f3fc99a1f3d8fc51683fba/artifacts/verification/initial_full_real.json ; https://github.com/thisisbread1999/statistical-analysis-assistant/blob/9a8fa007c5165b75c2f3fc99a1f3d8fc51683fba/artifacts/verification/first_targeted_real.json ; https://github.com/thisisbread1999/statistical-analysis-assistant/blob/9a8fa007c5165b75c2f3fc99a1f3d8fc51683fba/artifacts/verification/final_targeted_real.json ; https://github.com/thisisbread1999/statistical-analysis-assistant/blob/9a8fa007c5165b75c2f3fc99a1f3d8fc51683fba/docs/VERIFICATION.md</a:t>
+              <a:t>Sources: https://github.com/thisisbread1999/statistical-analysis-assistant/blob/4ebe82c/docs/HUMAN_EVALUATION_RUBRIC.md ; https://github.com/thisisbread1999/statistical-analysis-assistant/blob/4ebe82c/artifacts/benchmark_v2/20261012-live-blinded/human_review.csv ; https://github.com/thisisbread1999/statistical-analysis-assistant/blob/4ebe82c/stat_assistant/methods.py ; https://github.com/thisisbread1999/statistical-analysis-assistant/blob/4ebe82c/examples/benchmark_v2/manifest.json</a:t>
             </a:r>
           </a:p>
         </p:txBody>
@@ -2589,12 +2589,12 @@
   </p:cSld>
   <p:clrMap bg1="lt1" tx1="dk1" bg2="lt2" tx2="dk2" accent1="accent1" accent2="accent2" accent3="accent3" accent4="accent4" accent5="accent5" accent6="accent6" hlink="hlink" folHlink="folHlink"/>
   <p:sldLayoutIdLst>
-    <p:sldLayoutId xmlns:r="http://schemas.openxmlformats.org/officeDocument/2006/relationships" id="2147483649" r:id="Re58b85a4ccca4318"/>
-    <p:sldLayoutId xmlns:r="http://schemas.openxmlformats.org/officeDocument/2006/relationships" id="2147483650" r:id="Ra64ad3c170cb42d5"/>
-    <p:sldLayoutId xmlns:r="http://schemas.openxmlformats.org/officeDocument/2006/relationships" id="2147483651" r:id="Rfb3aebaf3862482f"/>
-    <p:sldLayoutId xmlns:r="http://schemas.openxmlformats.org/officeDocument/2006/relationships" id="2147483652" r:id="R8fbea09ad9fc4ccb"/>
-    <p:sldLayoutId xmlns:r="http://schemas.openxmlformats.org/officeDocument/2006/relationships" id="2147483653" r:id="Rf7866eb3b0b543d8"/>
-    <p:sldLayoutId xmlns:r="http://schemas.openxmlformats.org/officeDocument/2006/relationships" id="2147483654" r:id="R6b71bd5fa9884897"/>
+    <p:sldLayoutId xmlns:r="http://schemas.openxmlformats.org/officeDocument/2006/relationships" id="2147483649" r:id="Rceda08659a864fd1"/>
+    <p:sldLayoutId xmlns:r="http://schemas.openxmlformats.org/officeDocument/2006/relationships" id="2147483650" r:id="R8cb7efdffa374cdc"/>
+    <p:sldLayoutId xmlns:r="http://schemas.openxmlformats.org/officeDocument/2006/relationships" id="2147483651" r:id="Rfa312475001a4c21"/>
+    <p:sldLayoutId xmlns:r="http://schemas.openxmlformats.org/officeDocument/2006/relationships" id="2147483652" r:id="R2804c044598444b0"/>
+    <p:sldLayoutId xmlns:r="http://schemas.openxmlformats.org/officeDocument/2006/relationships" id="2147483653" r:id="Rd8a687278f184a81"/>
+    <p:sldLayoutId xmlns:r="http://schemas.openxmlformats.org/officeDocument/2006/relationships" id="2147483654" r:id="R28de0ef6368f4f5e"/>
   </p:sldLayoutIdLst>
   <p:txStyles>
     <p:titleStyle>
@@ -4198,7 +4198,7 @@
                 <a:ea typeface="Calibri"/>
                 <a:cs typeface="Calibri"/>
               </a:rPr>
-              <a:t>CLI + notebooks   •   Two distinct models   •   Session memory   •   Bounded retries</a:t>
+              <a:t>Local UI, CLI and notebooks   •   Two distinct models   •   Session memory</a:t>
             </a:r>
           </a:p>
         </p:txBody>
@@ -5465,7 +5465,7 @@
                 <a:ea typeface="Calibri"/>
                 <a:cs typeface="Calibri"/>
               </a:rPr>
-              <a:t>Record reasons and versions</a:t>
+              <a:t>Record decisions and versions</a:t>
             </a:r>
           </a:p>
         </p:txBody>
@@ -7923,7 +7923,7 @@
                 <a:ea typeface="Calibri"/>
                 <a:cs typeface="Calibri"/>
               </a:rPr>
-              <a:t>93 offline tests</a:t>
+              <a:t>192 tests</a:t>
             </a:r>
           </a:p>
         </p:txBody>
@@ -7990,7 +7990,7 @@
                 <a:ea typeface="Calibri"/>
                 <a:cs typeface="Calibri"/>
               </a:rPr>
-              <a:t>Mock agents; real statistics</a:t>
+              <a:t>Software checks passed</a:t>
             </a:r>
           </a:p>
           <a:p xmlns:a="http://schemas.openxmlformats.org/drawingml/2006/main">
@@ -8014,7 +8014,7 @@
                 <a:ea typeface="Calibri"/>
                 <a:cs typeface="Calibri"/>
               </a:rPr>
-              <a:t>Workflow and report checks</a:t>
+              <a:t>Mock models + real statistics</a:t>
             </a:r>
           </a:p>
         </p:txBody>
@@ -8081,7 +8081,7 @@
                 <a:ea typeface="Calibri"/>
                 <a:cs typeface="Calibri"/>
               </a:rPr>
-              <a:t>Real runs</a:t>
+              <a:t>27 / 31</a:t>
             </a:r>
           </a:p>
         </p:txBody>
@@ -8148,7 +8148,7 @@
                 <a:ea typeface="Calibri"/>
                 <a:cs typeface="Calibri"/>
               </a:rPr>
-              <a:t>Four methods + follow-ups</a:t>
+              <a:t>Live workflow checks</a:t>
             </a:r>
           </a:p>
           <a:p xmlns:a="http://schemas.openxmlformats.org/drawingml/2006/main">
@@ -8172,7 +8172,7 @@
                 <a:ea typeface="Calibri"/>
                 <a:cs typeface="Calibri"/>
               </a:rPr>
-              <a:t>Initial + targeted reruns</a:t>
+              <a:t>Failures retained</a:t>
             </a:r>
           </a:p>
         </p:txBody>
@@ -8239,7 +8239,7 @@
                 <a:ea typeface="Calibri"/>
                 <a:cs typeface="Calibri"/>
               </a:rPr>
-              <a:t>Human review</a:t>
+              <a:t>10 / 12</a:t>
             </a:r>
           </a:p>
         </p:txBody>
@@ -8306,7 +8306,7 @@
                 <a:ea typeface="Calibri"/>
                 <a:cs typeface="Calibri"/>
               </a:rPr>
-              <a:t>Independent scoring pending</a:t>
+              <a:t>Planted errors caught</a:t>
             </a:r>
           </a:p>
           <a:p xmlns:a="http://schemas.openxmlformats.org/drawingml/2006/main">
@@ -8330,7 +8330,7 @@
                 <a:ea typeface="Calibri"/>
                 <a:cs typeface="Calibri"/>
               </a:rPr>
-              <a:t>No semantic accuracy estimate</a:t>
+              <a:t>Human scoring pending</a:t>
             </a:r>
           </a:p>
         </p:txBody>
@@ -8493,7 +8493,7 @@
                 <a:ea typeface="Calibri"/>
                 <a:cs typeface="Calibri"/>
               </a:rPr>
-              <a:t>Observed failure and remaining work</a:t>
+              <a:t>Future work</a:t>
             </a:r>
           </a:p>
         </p:txBody>
@@ -8724,7 +8724,7 @@
                 <a:ea typeface="Calibri"/>
                 <a:cs typeface="Calibri"/>
               </a:rPr>
-              <a:t>HISTORICAL REAL RUN / Pearson and OLS reports were withheld</a:t>
+              <a:t>CURRENT SCOPE / Four methods, synthetic benchmarks, human data decisions</a:t>
             </a:r>
           </a:p>
         </p:txBody>
@@ -8821,7 +8821,7 @@
                 <a:ea typeface="Calibri"/>
                 <a:cs typeface="Calibri"/>
               </a:rPr>
-              <a:t>A valid H0 was blocked by the report checker</a:t>
+              <a:t>Independent human scoring is the next evaluation step</a:t>
             </a:r>
           </a:p>
         </p:txBody>
@@ -8888,7 +8888,7 @@
                 <a:ea typeface="Calibri"/>
                 <a:cs typeface="Calibri"/>
               </a:rPr>
-              <a:t>What failed</a:t>
+              <a:t>Human evaluation</a:t>
             </a:r>
           </a:p>
         </p:txBody>
@@ -8955,7 +8955,7 @@
                 <a:ea typeface="Calibri"/>
                 <a:cs typeface="Calibri"/>
               </a:rPr>
-              <a:t>Literal hypothesis zero</a:t>
+              <a:t>Score methods and numbers</a:t>
             </a:r>
           </a:p>
           <a:p xmlns:a="http://schemas.openxmlformats.org/drawingml/2006/main">
@@ -8979,7 +8979,31 @@
                 <a:ea typeface="Calibri"/>
                 <a:cs typeface="Calibri"/>
               </a:rPr>
-              <a:t>clashed with placeholder rules</a:t>
+              <a:t>Check statistical meaning</a:t>
+            </a:r>
+          </a:p>
+          <a:p xmlns:a="http://schemas.openxmlformats.org/drawingml/2006/main">
+            <a:pPr>
+              <a:buNone/>
+              <a:defRPr sz="2025" b="0">
+                <a:solidFill>
+                  <a:srgbClr val="183D36"/>
+                </a:solidFill>
+                <a:latin typeface="Calibri"/>
+                <a:ea typeface="Calibri"/>
+                <a:cs typeface="Calibri"/>
+              </a:defRPr>
+            </a:pPr>
+            <a:r>
+              <a:rPr sz="2025" b="0">
+                <a:solidFill>
+                  <a:srgbClr val="183D36"/>
+                </a:solidFill>
+                <a:latin typeface="Calibri"/>
+                <a:ea typeface="Calibri"/>
+                <a:cs typeface="Calibri"/>
+              </a:rPr>
+              <a:t>Human ratings pending</a:t>
             </a:r>
           </a:p>
         </p:txBody>
@@ -9046,7 +9070,7 @@
                 <a:ea typeface="Calibri"/>
                 <a:cs typeface="Calibri"/>
               </a:rPr>
-              <a:t>What we fixed</a:t>
+              <a:t>More methods</a:t>
             </a:r>
           </a:p>
         </p:txBody>
@@ -9113,7 +9137,7 @@
                 <a:ea typeface="Calibri"/>
                 <a:cs typeface="Calibri"/>
               </a:rPr>
-              <a:t>Protected null values</a:t>
+              <a:t>Paired tests</a:t>
             </a:r>
           </a:p>
           <a:p xmlns:a="http://schemas.openxmlformats.org/drawingml/2006/main">
@@ -9137,7 +9161,31 @@
                 <a:ea typeface="Calibri"/>
                 <a:cs typeface="Calibri"/>
               </a:rPr>
-              <a:t>Separated null and estimate</a:t>
+              <a:t>Multiple regression</a:t>
+            </a:r>
+          </a:p>
+          <a:p xmlns:a="http://schemas.openxmlformats.org/drawingml/2006/main">
+            <a:pPr>
+              <a:buNone/>
+              <a:defRPr sz="2025" b="0">
+                <a:solidFill>
+                  <a:srgbClr val="183D36"/>
+                </a:solidFill>
+                <a:latin typeface="Calibri"/>
+                <a:ea typeface="Calibri"/>
+                <a:cs typeface="Calibri"/>
+              </a:defRPr>
+            </a:pPr>
+            <a:r>
+              <a:rPr sz="2025" b="0">
+                <a:solidFill>
+                  <a:srgbClr val="183D36"/>
+                </a:solidFill>
+                <a:latin typeface="Calibri"/>
+                <a:ea typeface="Calibri"/>
+                <a:cs typeface="Calibri"/>
+              </a:rPr>
+              <a:t>Route by study design</a:t>
             </a:r>
           </a:p>
         </p:txBody>
@@ -9204,7 +9252,7 @@
                 <a:ea typeface="Calibri"/>
                 <a:cs typeface="Calibri"/>
               </a:rPr>
-              <a:t>What remains</a:t>
+              <a:t>Real-world datasets</a:t>
             </a:r>
           </a:p>
         </p:txBody>
@@ -9271,7 +9319,7 @@
                 <a:ea typeface="Calibri"/>
                 <a:cs typeface="Calibri"/>
               </a:rPr>
-              <a:t>Reviewer false alarms</a:t>
+              <a:t>Public data, e.g. Kaggle</a:t>
             </a:r>
           </a:p>
           <a:p xmlns:a="http://schemas.openxmlformats.org/drawingml/2006/main">
@@ -9295,7 +9343,31 @@
                 <a:ea typeface="Calibri"/>
                 <a:cs typeface="Calibri"/>
               </a:rPr>
-              <a:t>Human semantic scoring pending</a:t>
+              <a:t>Verify source and design</a:t>
+            </a:r>
+          </a:p>
+          <a:p xmlns:a="http://schemas.openxmlformats.org/drawingml/2006/main">
+            <a:pPr>
+              <a:buNone/>
+              <a:defRPr sz="2025" b="0">
+                <a:solidFill>
+                  <a:srgbClr val="183D36"/>
+                </a:solidFill>
+                <a:latin typeface="Calibri"/>
+                <a:ea typeface="Calibri"/>
+                <a:cs typeface="Calibri"/>
+              </a:defRPr>
+            </a:pPr>
+            <a:r>
+              <a:rPr sz="2025" b="0">
+                <a:solidFill>
+                  <a:srgbClr val="183D36"/>
+                </a:solidFill>
+                <a:latin typeface="Calibri"/>
+                <a:ea typeface="Calibri"/>
+                <a:cs typeface="Calibri"/>
+              </a:rPr>
+              <a:t>Expert reference analyses</a:t>
             </a:r>
           </a:p>
         </p:txBody>
@@ -9362,7 +9434,7 @@
                 <a:ea typeface="Calibri"/>
                 <a:cs typeface="Calibri"/>
               </a:rPr>
-              <a:t>Repair delivered Pearson and OLS. Two-model agreement still needs human evaluation.</a:t>
+              <a:t>Human ratings and real-world dataset results remain pending</a:t>
             </a:r>
           </a:p>
         </p:txBody>

</xml_diff>